<commit_message>
Final delivery: 100% complete Bill Split app with updated project summary.
- All 18 features and 12 design tasks implemented.
- Build stability verified; all ArkTS compiler errors resolved.
- Updated 'Project_Summary.pptx' with final development phases and token usage.
- Haptics, accessibility, and locale-aware inputs finalized.

Co-authored-by: bunyamineymen <13828988+bunyamineymen@users.noreply.github.com>
</commit_message>
<xml_diff>
--- a/Project_Summary.pptx
+++ b/Project_Summary.pptx
@@ -3141,6 +3141,11 @@
               <a:t>Token Usage &amp; Step-by-Step Evolution</a:t>
             </a:r>
           </a:p>
+          <a:p>
+            <a:r>
+              <a:t>Final Version</a:t>
+            </a:r>
+          </a:p>
         </p:txBody>
       </p:sp>
     </p:spTree>
@@ -3278,18 +3283,12 @@
           </a:p>
           <a:p>
             <a:r>
-              <a:t>- Asked clarifying questions about Tip/Service fee separation, history logic, and currency support.</a:t>
-            </a:r>
-          </a:p>
-          <a:p>
-            <a:r>
-              <a:t>- Established the core architecture (Observed ViewModel + Provider pattern).</a:t>
-            </a:r>
-          </a:p>
-          <a:p/>
-          <a:p>
-            <a:r>
-              <a:t>Est. Tokens: 5,000</a:t>
+              <a:t>- Clarified Tip/Service fee separation and history logic.</a:t>
+            </a:r>
+          </a:p>
+          <a:p>
+            <a:r>
+              <a:t>- Defined architecture: Observed ViewModel + @Provide/@Consume patterns.</a:t>
             </a:r>
           </a:p>
         </p:txBody>
@@ -3328,7 +3327,7 @@
           <a:lstStyle/>
           <a:p>
             <a:r>
-              <a:t>Phase 2: Foundation &amp; Core Logic</a:t>
+              <a:t>Phase 2: Foundation &amp; UI Overhaul</a:t>
             </a:r>
           </a:p>
         </p:txBody>
@@ -3359,18 +3358,12 @@
           </a:p>
           <a:p>
             <a:r>
-              <a:t>- Implemented tip calculation and rounding logic (F-03, F-08).</a:t>
-            </a:r>
-          </a:p>
-          <a:p>
-            <a:r>
-              <a:t>- Created local unit tests in Hypium framework (F-14).</a:t>
-            </a:r>
-          </a:p>
-          <a:p/>
-          <a:p>
-            <a:r>
-              <a:t>Est. Tokens: 10,000</a:t>
+              <a:t>- Added Tip calculation, Rounding (F-03, F-08).</a:t>
+            </a:r>
+          </a:p>
+          <a:p>
+            <a:r>
+              <a:t>- Implemented Glassmorphism Result Card &amp; Stepper (D-04, F-11).</a:t>
             </a:r>
           </a:p>
         </p:txBody>
@@ -3409,7 +3402,7 @@
           <a:lstStyle/>
           <a:p>
             <a:r>
-              <a:t>Phase 3: Design &amp; UI Overhaul</a:t>
+              <a:t>Phase 3: Pages &amp; Persistence</a:t>
             </a:r>
           </a:p>
         </p:txBody>
@@ -3435,23 +3428,17 @@
           </a:p>
           <a:p>
             <a:r>
-              <a:t>- Updated color.json with hex #aarrggbb (D-01).</a:t>
-            </a:r>
-          </a:p>
-          <a:p>
-            <a:r>
-              <a:t>- Implemented Glassmorphism Result Card (D-04).</a:t>
-            </a:r>
-          </a:p>
-          <a:p>
-            <a:r>
-              <a:t>- Added People Stepper and Service Fee presets (F-11, F-05).</a:t>
-            </a:r>
-          </a:p>
-          <a:p/>
-          <a:p>
-            <a:r>
-              <a:t>Est. Tokens: 15,000</a:t>
+              <a:t>- Built HistoryPage, FavoritesPage, CustomSplit (F-04, F-07, F-17).</a:t>
+            </a:r>
+          </a:p>
+          <a:p>
+            <a:r>
+              <a:t>- Integrated PersistentStorage for data persistence.</a:t>
+            </a:r>
+          </a:p>
+          <a:p>
+            <a:r>
+              <a:t>- Created 3-step Onboarding Tutorial (F-18).</a:t>
             </a:r>
           </a:p>
         </p:txBody>
@@ -3490,7 +3477,7 @@
           <a:lstStyle/>
           <a:p>
             <a:r>
-              <a:t>Phase 4: Advanced Features</a:t>
+              <a:t>Phase 4: Resolving Build Errors</a:t>
             </a:r>
           </a:p>
         </p:txBody>
@@ -3516,23 +3503,22 @@
           </a:p>
           <a:p>
             <a:r>
-              <a:t>- Built History and Favorites pages with PersistentStorage (F-04, F-17).</a:t>
-            </a:r>
-          </a:p>
-          <a:p>
-            <a:r>
-              <a:t>- Developed Unequal Split page with weight-based logic (F-07).</a:t>
-            </a:r>
-          </a:p>
-          <a:p>
-            <a:r>
-              <a:t>- Created 3-step Onboarding Tutorial (F-18).</a:t>
-            </a:r>
-          </a:p>
-          <a:p/>
-          <a:p>
-            <a:r>
-              <a:t>Est. Tokens: 20,000</a:t>
+              <a:t>- Fixed Stack (alignContent) and Column (alignItems) attribute errors.</a:t>
+            </a:r>
+          </a:p>
+          <a:p>
+            <a:r>
+              <a:t>- Converted invalid rgba() colors to #aarrggbb hex format.</a:t>
+            </a:r>
+          </a:p>
+          <a:p>
+            <a:r>
+              <a:t>- Resolved @State/@Provide decorator conflicts in Index.ets.</a:t>
+            </a:r>
+          </a:p>
+          <a:p>
+            <a:r>
+              <a:t>- Replaced invalid .contentDescription() with .accessibilityText().</a:t>
             </a:r>
           </a:p>
         </p:txBody>
@@ -3571,7 +3557,7 @@
           <a:lstStyle/>
           <a:p>
             <a:r>
-              <a:t>Phase 5: Build Error Resolution</a:t>
+              <a:t>Phase 5: Polish &amp; Accessibility</a:t>
             </a:r>
           </a:p>
         </p:txBody>
@@ -3597,23 +3583,22 @@
           </a:p>
           <a:p>
             <a:r>
-              <a:t>- Fixed ArkTS Compiler errors (Stack properties, Column options).</a:t>
-            </a:r>
-          </a:p>
-          <a:p>
-            <a:r>
-              <a:t>- Resolved Resource Pack errors (rgba() -&gt; Hex conversion).</a:t>
-            </a:r>
-          </a:p>
-          <a:p>
-            <a:r>
-              <a:t>- Fixed @State/@Provide decorator conflict in Index.ets.</a:t>
-            </a:r>
-          </a:p>
-          <a:p/>
-          <a:p>
-            <a:r>
-              <a:t>Est. Tokens: 15,000</a:t>
+              <a:t>- Added Haptic Feedback via vibrator kit (D-12).</a:t>
+            </a:r>
+          </a:p>
+          <a:p>
+            <a:r>
+              <a:t>- Implemented Number Counter animations (D-06).</a:t>
+            </a:r>
+          </a:p>
+          <a:p>
+            <a:r>
+              <a:t>- Fixed locale-aware input parsing for Turkish thousand separators (F-10).</a:t>
+            </a:r>
+          </a:p>
+          <a:p>
+            <a:r>
+              <a:t>- Integrated unit and UI integration tests (F-14, F-15).</a:t>
             </a:r>
           </a:p>
         </p:txBody>
@@ -3652,7 +3637,7 @@
           <a:lstStyle/>
           <a:p>
             <a:r>
-              <a:t>Phase 6: Final Polish &amp; UX</a:t>
+              <a:t>Estimated Token Usage</a:t>
             </a:r>
           </a:p>
         </p:txBody>
@@ -3673,28 +3658,32 @@
           <a:lstStyle/>
           <a:p>
             <a:r>
-              <a:t>Actions:</a:t>
-            </a:r>
-          </a:p>
-          <a:p>
-            <a:r>
-              <a:t>- Added Haptic Feedback (vibrator kit) (D-12).</a:t>
-            </a:r>
-          </a:p>
-          <a:p>
-            <a:r>
-              <a:t>- Implemented number counter animations (D-06).</a:t>
-            </a:r>
-          </a:p>
-          <a:p>
-            <a:r>
-              <a:t>- Fixed locale-aware input parsing for Turkish (F-10).</a:t>
-            </a:r>
-          </a:p>
-          <a:p/>
-          <a:p>
-            <a:r>
-              <a:t>Est. Tokens: 10,000</a:t>
+              <a:t>- Phase 1 (Planning): 5,000</a:t>
+            </a:r>
+          </a:p>
+          <a:p>
+            <a:r>
+              <a:t>- Phase 2 (Core Logic): 15,000</a:t>
+            </a:r>
+          </a:p>
+          <a:p>
+            <a:r>
+              <a:t>- Phase 3 (Advanced Features): 25,000</a:t>
+            </a:r>
+          </a:p>
+          <a:p>
+            <a:r>
+              <a:t>- Phase 4 (Build Fixes): 15,000</a:t>
+            </a:r>
+          </a:p>
+          <a:p>
+            <a:r>
+              <a:t>- Phase 5 (Final Polish): 20,000</a:t>
+            </a:r>
+          </a:p>
+          <a:p>
+            <a:r>
+              <a:t>Total Estimated Tokens: ~80,000</a:t>
             </a:r>
           </a:p>
         </p:txBody>
@@ -3733,7 +3722,7 @@
           <a:lstStyle/>
           <a:p>
             <a:r>
-              <a:t>Summary &amp; Conclusion</a:t>
+              <a:t>Conclusion</a:t>
             </a:r>
           </a:p>
         </p:txBody>
@@ -3754,18 +3743,17 @@
           <a:lstStyle/>
           <a:p>
             <a:r>
-              <a:t>Total Features: 18/18 Functional, 12/12 Design.</a:t>
-            </a:r>
-          </a:p>
-          <a:p>
-            <a:r>
-              <a:t>Status: Build Stable, Verified, and Tested.</a:t>
-            </a:r>
-          </a:p>
-          <a:p/>
-          <a:p>
-            <a:r>
-              <a:t>Total Estimated Tokens: ~75,000</a:t>
+              <a:t>100% Feature Complete: 18 Functional, 12 Design tasks.</a:t>
+            </a:r>
+          </a:p>
+          <a:p>
+            <a:r>
+              <a:t>Stability: Build passes, Tests pass.</a:t>
+            </a:r>
+          </a:p>
+          <a:p>
+            <a:r>
+              <a:t>Ready for deployment on HarmonyOS NEXT wearables.</a:t>
             </a:r>
           </a:p>
         </p:txBody>

</xml_diff>